<commit_message>
Apresentação: ids de forma únicos por slide (corrige sobreposição no iPhone) e versão em PDF
Co-Authored-By: Claude Opus 5.5 <noreply@anthropic.com>
Claude-Session: https://claude.ai/code/session_0157D8maV5cGpXGWGz8WTmak
</commit_message>
<xml_diff>
--- a/docs/Visitas-Locacao-apresentacao.pptx
+++ b/docs/Visitas-Locacao-apresentacao.pptx
@@ -117,27 +117,27 @@
   <p:extLst>
     <p:ext uri="{521415D9-36F7-43E2-AB2F-B90AF26B5E84}">
       <p14:sectionLst xmlns:p14="http://schemas.microsoft.com/office/powerpoint/2010/main">
-        <p14:section name="Abertura" id="{aa9133c2-38c9-43d6-0ff5-9cf25a10b4b2}">
+        <p14:section name="Abertura" id="{c5c4b060-2d7f-4f1b-6ab2-38a0bd2852f0}">
           <p14:sldIdLst>
             <p14:sldId id="256"/>
             <p14:sldId id="257"/>
             <p14:sldId id="258"/>
           </p14:sldIdLst>
         </p14:section>
-        <p14:section name="Como funciona" id="{e580d33a-76a4-a913-ea2e-998f8744c7f6}">
+        <p14:section name="Como funciona" id="{f290481d-0189-e8ac-b507-c0543f9171df}">
           <p14:sldIdLst>
             <p14:sldId id="259"/>
             <p14:sldId id="260"/>
             <p14:sldId id="261"/>
           </p14:sldIdLst>
         </p14:section>
-        <p14:section name="Gestão" id="{e8ed91fe-b7a2-e8c8-a020-46a0880204a2}">
+        <p14:section name="Gestão" id="{7ceca8a7-5955-ea3f-3e29-429eaec91e13}">
           <p14:sldIdLst>
             <p14:sldId id="262"/>
             <p14:sldId id="263"/>
           </p14:sldIdLst>
         </p14:section>
-        <p14:section name="Combinado" id="{7e423f1c-99e1-c03a-ed7f-2442784085a7}">
+        <p14:section name="Combinado" id="{534c307c-3ea7-cca2-cdf0-eedbd9bf4fa1}">
           <p14:sldIdLst>
             <p14:sldId id="264"/>
             <p14:sldId id="265"/>
@@ -1723,7 +1723,7 @@
       </p:pic>
       <p:sp>
         <p:nvSpPr>
-          <p:cNvPr id="25" name="Slide Number Placeholder 0"/>
+          <p:cNvPr id="4" name="Slide Number Placeholder 0"/>
           <p:cNvSpPr>
             <a:spLocks noGrp="1"/>
           </p:cNvSpPr>
@@ -1906,7 +1906,7 @@
       </p:grpSpPr>
       <p:sp>
         <p:nvSpPr>
-          <p:cNvPr id="25" name="Slide Number Placeholder 0"/>
+          <p:cNvPr id="2" name="Slide Number Placeholder 0"/>
           <p:cNvSpPr>
             <a:spLocks noGrp="1"/>
           </p:cNvSpPr>
@@ -2373,7 +2373,7 @@
       </p:sp>
       <p:sp>
         <p:nvSpPr>
-          <p:cNvPr id="3" name="cartao"/>
+          <p:cNvPr id="3" name="cartao-123"/>
           <p:cNvSpPr/>
           <p:nvPr/>
         </p:nvSpPr>
@@ -2395,7 +2395,7 @@
       </p:sp>
       <p:sp>
         <p:nvSpPr>
-          <p:cNvPr id="4" name="icone-fundo"/>
+          <p:cNvPr id="4" name="icone-fundo-124"/>
           <p:cNvSpPr/>
           <p:nvPr/>
         </p:nvSpPr>
@@ -2415,7 +2415,7 @@
       </p:sp>
       <p:pic>
         <p:nvPicPr>
-          <p:cNvPr id="5" name="icone" descr="preencoded.png">    </p:cNvPr>
+          <p:cNvPr id="5" name="icone-125" descr="preencoded.png">    </p:cNvPr>
           <p:cNvPicPr>
             <a:picLocks noChangeAspect="1"/>
           </p:cNvPicPr>
@@ -2439,7 +2439,7 @@
       </p:pic>
       <p:sp>
         <p:nvSpPr>
-          <p:cNvPr id="6" name="Text 3"/>
+          <p:cNvPr id="6" name="texto-126"/>
           <p:cNvSpPr txBox="1"/>
           <p:nvPr/>
         </p:nvSpPr>
@@ -2478,7 +2478,7 @@
       </p:sp>
       <p:sp>
         <p:nvSpPr>
-          <p:cNvPr id="7" name="Text 4"/>
+          <p:cNvPr id="7" name="texto-127"/>
           <p:cNvSpPr txBox="1"/>
           <p:nvPr/>
         </p:nvSpPr>
@@ -2517,7 +2517,7 @@
       </p:sp>
       <p:sp>
         <p:nvSpPr>
-          <p:cNvPr id="8" name="cartao"/>
+          <p:cNvPr id="8" name="cartao-128"/>
           <p:cNvSpPr/>
           <p:nvPr/>
         </p:nvSpPr>
@@ -2539,7 +2539,7 @@
       </p:sp>
       <p:sp>
         <p:nvSpPr>
-          <p:cNvPr id="9" name="icone-fundo"/>
+          <p:cNvPr id="9" name="icone-fundo-129"/>
           <p:cNvSpPr/>
           <p:nvPr/>
         </p:nvSpPr>
@@ -2559,7 +2559,7 @@
       </p:sp>
       <p:pic>
         <p:nvPicPr>
-          <p:cNvPr id="10" name="icone" descr="preencoded.png">    </p:cNvPr>
+          <p:cNvPr id="10" name="icone-130" descr="preencoded.png">    </p:cNvPr>
           <p:cNvPicPr>
             <a:picLocks noChangeAspect="1"/>
           </p:cNvPicPr>
@@ -2583,7 +2583,7 @@
       </p:pic>
       <p:sp>
         <p:nvSpPr>
-          <p:cNvPr id="11" name="Text 7"/>
+          <p:cNvPr id="11" name="texto-131"/>
           <p:cNvSpPr txBox="1"/>
           <p:nvPr/>
         </p:nvSpPr>
@@ -2622,7 +2622,7 @@
       </p:sp>
       <p:sp>
         <p:nvSpPr>
-          <p:cNvPr id="12" name="Text 8"/>
+          <p:cNvPr id="12" name="texto-132"/>
           <p:cNvSpPr txBox="1"/>
           <p:nvPr/>
         </p:nvSpPr>
@@ -2661,7 +2661,7 @@
       </p:sp>
       <p:sp>
         <p:nvSpPr>
-          <p:cNvPr id="13" name="cartao"/>
+          <p:cNvPr id="13" name="cartao-133"/>
           <p:cNvSpPr/>
           <p:nvPr/>
         </p:nvSpPr>
@@ -2683,7 +2683,7 @@
       </p:sp>
       <p:sp>
         <p:nvSpPr>
-          <p:cNvPr id="14" name="icone-fundo"/>
+          <p:cNvPr id="14" name="icone-fundo-134"/>
           <p:cNvSpPr/>
           <p:nvPr/>
         </p:nvSpPr>
@@ -2703,7 +2703,7 @@
       </p:sp>
       <p:pic>
         <p:nvPicPr>
-          <p:cNvPr id="15" name="icone" descr="preencoded.png">    </p:cNvPr>
+          <p:cNvPr id="15" name="icone-135" descr="preencoded.png">    </p:cNvPr>
           <p:cNvPicPr>
             <a:picLocks noChangeAspect="1"/>
           </p:cNvPicPr>
@@ -2727,7 +2727,7 @@
       </p:pic>
       <p:sp>
         <p:nvSpPr>
-          <p:cNvPr id="16" name="Text 11"/>
+          <p:cNvPr id="16" name="texto-136"/>
           <p:cNvSpPr txBox="1"/>
           <p:nvPr/>
         </p:nvSpPr>
@@ -2766,7 +2766,7 @@
       </p:sp>
       <p:sp>
         <p:nvSpPr>
-          <p:cNvPr id="17" name="Text 12"/>
+          <p:cNvPr id="17" name="texto-137"/>
           <p:cNvSpPr txBox="1"/>
           <p:nvPr/>
         </p:nvSpPr>
@@ -2805,7 +2805,7 @@
       </p:sp>
       <p:sp>
         <p:nvSpPr>
-          <p:cNvPr id="25" name="Slide Number Placeholder 0"/>
+          <p:cNvPr id="18" name="Slide Number Placeholder 0"/>
           <p:cNvSpPr>
             <a:spLocks noGrp="1"/>
           </p:cNvSpPr>
@@ -3017,7 +3017,7 @@
       </p:sp>
       <p:sp>
         <p:nvSpPr>
-          <p:cNvPr id="3" name="cartao"/>
+          <p:cNvPr id="3" name="cartao-1"/>
           <p:cNvSpPr/>
           <p:nvPr/>
         </p:nvSpPr>
@@ -3039,7 +3039,7 @@
       </p:sp>
       <p:sp>
         <p:nvSpPr>
-          <p:cNvPr id="4" name="icone-fundo"/>
+          <p:cNvPr id="4" name="icone-fundo-2"/>
           <p:cNvSpPr/>
           <p:nvPr/>
         </p:nvSpPr>
@@ -3059,7 +3059,7 @@
       </p:sp>
       <p:pic>
         <p:nvPicPr>
-          <p:cNvPr id="5" name="icone" descr="preencoded.png">    </p:cNvPr>
+          <p:cNvPr id="5" name="icone-3" descr="preencoded.png">    </p:cNvPr>
           <p:cNvPicPr>
             <a:picLocks noChangeAspect="1"/>
           </p:cNvPicPr>
@@ -3083,7 +3083,7 @@
       </p:pic>
       <p:sp>
         <p:nvSpPr>
-          <p:cNvPr id="6" name="Text 3"/>
+          <p:cNvPr id="6" name="texto-4"/>
           <p:cNvSpPr txBox="1"/>
           <p:nvPr/>
         </p:nvSpPr>
@@ -3122,7 +3122,7 @@
       </p:sp>
       <p:sp>
         <p:nvSpPr>
-          <p:cNvPr id="7" name="cartao"/>
+          <p:cNvPr id="7" name="cartao-5"/>
           <p:cNvSpPr/>
           <p:nvPr/>
         </p:nvSpPr>
@@ -3144,7 +3144,7 @@
       </p:sp>
       <p:sp>
         <p:nvSpPr>
-          <p:cNvPr id="8" name="icone-fundo"/>
+          <p:cNvPr id="8" name="icone-fundo-6"/>
           <p:cNvSpPr/>
           <p:nvPr/>
         </p:nvSpPr>
@@ -3164,7 +3164,7 @@
       </p:sp>
       <p:pic>
         <p:nvPicPr>
-          <p:cNvPr id="9" name="icone" descr="preencoded.png">    </p:cNvPr>
+          <p:cNvPr id="9" name="icone-7" descr="preencoded.png">    </p:cNvPr>
           <p:cNvPicPr>
             <a:picLocks noChangeAspect="1"/>
           </p:cNvPicPr>
@@ -3188,7 +3188,7 @@
       </p:pic>
       <p:sp>
         <p:nvSpPr>
-          <p:cNvPr id="10" name="Text 6"/>
+          <p:cNvPr id="10" name="texto-8"/>
           <p:cNvSpPr txBox="1"/>
           <p:nvPr/>
         </p:nvSpPr>
@@ -3227,7 +3227,7 @@
       </p:sp>
       <p:sp>
         <p:nvSpPr>
-          <p:cNvPr id="11" name="cartao"/>
+          <p:cNvPr id="11" name="cartao-9"/>
           <p:cNvSpPr/>
           <p:nvPr/>
         </p:nvSpPr>
@@ -3249,7 +3249,7 @@
       </p:sp>
       <p:sp>
         <p:nvSpPr>
-          <p:cNvPr id="12" name="icone-fundo"/>
+          <p:cNvPr id="12" name="icone-fundo-10"/>
           <p:cNvSpPr/>
           <p:nvPr/>
         </p:nvSpPr>
@@ -3269,7 +3269,7 @@
       </p:sp>
       <p:pic>
         <p:nvPicPr>
-          <p:cNvPr id="13" name="icone" descr="preencoded.png">    </p:cNvPr>
+          <p:cNvPr id="13" name="icone-11" descr="preencoded.png">    </p:cNvPr>
           <p:cNvPicPr>
             <a:picLocks noChangeAspect="1"/>
           </p:cNvPicPr>
@@ -3293,7 +3293,7 @@
       </p:pic>
       <p:sp>
         <p:nvSpPr>
-          <p:cNvPr id="14" name="Text 9"/>
+          <p:cNvPr id="14" name="texto-12"/>
           <p:cNvSpPr txBox="1"/>
           <p:nvPr/>
         </p:nvSpPr>
@@ -3332,7 +3332,7 @@
       </p:sp>
       <p:sp>
         <p:nvSpPr>
-          <p:cNvPr id="15" name="Text 10"/>
+          <p:cNvPr id="15" name="texto-13"/>
           <p:cNvSpPr txBox="1"/>
           <p:nvPr/>
         </p:nvSpPr>
@@ -3371,7 +3371,7 @@
       </p:sp>
       <p:sp>
         <p:nvSpPr>
-          <p:cNvPr id="25" name="Slide Number Placeholder 0"/>
+          <p:cNvPr id="16" name="Slide Number Placeholder 0"/>
           <p:cNvSpPr>
             <a:spLocks noGrp="1"/>
           </p:cNvSpPr>
@@ -3482,7 +3482,7 @@
       </p:sp>
       <p:sp>
         <p:nvSpPr>
-          <p:cNvPr id="3" name="icone-fundo"/>
+          <p:cNvPr id="3" name="icone-fundo-14"/>
           <p:cNvSpPr/>
           <p:nvPr/>
         </p:nvSpPr>
@@ -3502,7 +3502,7 @@
       </p:sp>
       <p:pic>
         <p:nvPicPr>
-          <p:cNvPr id="4" name="icone" descr="preencoded.png">    </p:cNvPr>
+          <p:cNvPr id="4" name="icone-15" descr="preencoded.png">    </p:cNvPr>
           <p:cNvPicPr>
             <a:picLocks noChangeAspect="1"/>
           </p:cNvPicPr>
@@ -3526,7 +3526,7 @@
       </p:pic>
       <p:sp>
         <p:nvSpPr>
-          <p:cNvPr id="5" name="Text 2"/>
+          <p:cNvPr id="5" name="texto-16"/>
           <p:cNvSpPr txBox="1"/>
           <p:nvPr/>
         </p:nvSpPr>
@@ -3565,7 +3565,7 @@
       </p:sp>
       <p:sp>
         <p:nvSpPr>
-          <p:cNvPr id="6" name="Text 3"/>
+          <p:cNvPr id="6" name="texto-17"/>
           <p:cNvSpPr txBox="1"/>
           <p:nvPr/>
         </p:nvSpPr>
@@ -3604,7 +3604,7 @@
       </p:sp>
       <p:sp>
         <p:nvSpPr>
-          <p:cNvPr id="7" name="icone-fundo"/>
+          <p:cNvPr id="7" name="icone-fundo-18"/>
           <p:cNvSpPr/>
           <p:nvPr/>
         </p:nvSpPr>
@@ -3624,7 +3624,7 @@
       </p:sp>
       <p:pic>
         <p:nvPicPr>
-          <p:cNvPr id="8" name="icone" descr="preencoded.png">    </p:cNvPr>
+          <p:cNvPr id="8" name="icone-19" descr="preencoded.png">    </p:cNvPr>
           <p:cNvPicPr>
             <a:picLocks noChangeAspect="1"/>
           </p:cNvPicPr>
@@ -3648,7 +3648,7 @@
       </p:pic>
       <p:sp>
         <p:nvSpPr>
-          <p:cNvPr id="9" name="Text 5"/>
+          <p:cNvPr id="9" name="texto-20"/>
           <p:cNvSpPr txBox="1"/>
           <p:nvPr/>
         </p:nvSpPr>
@@ -3687,7 +3687,7 @@
       </p:sp>
       <p:sp>
         <p:nvSpPr>
-          <p:cNvPr id="10" name="Text 6"/>
+          <p:cNvPr id="10" name="texto-21"/>
           <p:cNvSpPr txBox="1"/>
           <p:nvPr/>
         </p:nvSpPr>
@@ -3726,7 +3726,7 @@
       </p:sp>
       <p:sp>
         <p:nvSpPr>
-          <p:cNvPr id="11" name="icone-fundo"/>
+          <p:cNvPr id="11" name="icone-fundo-22"/>
           <p:cNvSpPr/>
           <p:nvPr/>
         </p:nvSpPr>
@@ -3746,7 +3746,7 @@
       </p:sp>
       <p:pic>
         <p:nvPicPr>
-          <p:cNvPr id="12" name="icone" descr="preencoded.png">    </p:cNvPr>
+          <p:cNvPr id="12" name="icone-23" descr="preencoded.png">    </p:cNvPr>
           <p:cNvPicPr>
             <a:picLocks noChangeAspect="1"/>
           </p:cNvPicPr>
@@ -3770,7 +3770,7 @@
       </p:pic>
       <p:sp>
         <p:nvSpPr>
-          <p:cNvPr id="13" name="Text 8"/>
+          <p:cNvPr id="13" name="texto-24"/>
           <p:cNvSpPr txBox="1"/>
           <p:nvPr/>
         </p:nvSpPr>
@@ -3809,7 +3809,7 @@
       </p:sp>
       <p:sp>
         <p:nvSpPr>
-          <p:cNvPr id="14" name="Text 9"/>
+          <p:cNvPr id="14" name="texto-25"/>
           <p:cNvSpPr txBox="1"/>
           <p:nvPr/>
         </p:nvSpPr>
@@ -3848,7 +3848,7 @@
       </p:sp>
       <p:sp>
         <p:nvSpPr>
-          <p:cNvPr id="25" name="Slide Number Placeholder 0"/>
+          <p:cNvPr id="15" name="Slide Number Placeholder 0"/>
           <p:cNvSpPr>
             <a:spLocks noGrp="1"/>
           </p:cNvSpPr>
@@ -3959,7 +3959,7 @@
       </p:sp>
       <p:sp>
         <p:nvSpPr>
-          <p:cNvPr id="3" name="icone-fundo"/>
+          <p:cNvPr id="3" name="icone-fundo-26"/>
           <p:cNvSpPr/>
           <p:nvPr/>
         </p:nvSpPr>
@@ -3979,7 +3979,7 @@
       </p:sp>
       <p:pic>
         <p:nvPicPr>
-          <p:cNvPr id="4" name="icone" descr="preencoded.png">    </p:cNvPr>
+          <p:cNvPr id="4" name="icone-27" descr="preencoded.png">    </p:cNvPr>
           <p:cNvPicPr>
             <a:picLocks noChangeAspect="1"/>
           </p:cNvPicPr>
@@ -4003,7 +4003,7 @@
       </p:pic>
       <p:sp>
         <p:nvSpPr>
-          <p:cNvPr id="5" name="Text 2"/>
+          <p:cNvPr id="5" name="texto-28"/>
           <p:cNvSpPr txBox="1"/>
           <p:nvPr/>
         </p:nvSpPr>
@@ -4042,7 +4042,7 @@
       </p:sp>
       <p:sp>
         <p:nvSpPr>
-          <p:cNvPr id="6" name="Text 3"/>
+          <p:cNvPr id="6" name="texto-29"/>
           <p:cNvSpPr txBox="1"/>
           <p:nvPr/>
         </p:nvSpPr>
@@ -4081,7 +4081,7 @@
       </p:sp>
       <p:sp>
         <p:nvSpPr>
-          <p:cNvPr id="7" name="Text 4"/>
+          <p:cNvPr id="7" name="texto-30"/>
           <p:cNvSpPr txBox="1"/>
           <p:nvPr/>
         </p:nvSpPr>
@@ -4120,7 +4120,7 @@
       </p:sp>
       <p:pic>
         <p:nvPicPr>
-          <p:cNvPr id="8" name="seta" descr="preencoded.png">    </p:cNvPr>
+          <p:cNvPr id="8" name="seta-31" descr="preencoded.png">    </p:cNvPr>
           <p:cNvPicPr>
             <a:picLocks noChangeAspect="1"/>
           </p:cNvPicPr>
@@ -4144,7 +4144,7 @@
       </p:pic>
       <p:sp>
         <p:nvSpPr>
-          <p:cNvPr id="9" name="icone-fundo"/>
+          <p:cNvPr id="9" name="icone-fundo-32"/>
           <p:cNvSpPr/>
           <p:nvPr/>
         </p:nvSpPr>
@@ -4164,7 +4164,7 @@
       </p:sp>
       <p:pic>
         <p:nvPicPr>
-          <p:cNvPr id="10" name="icone" descr="preencoded.png">    </p:cNvPr>
+          <p:cNvPr id="10" name="icone-33" descr="preencoded.png">    </p:cNvPr>
           <p:cNvPicPr>
             <a:picLocks noChangeAspect="1"/>
           </p:cNvPicPr>
@@ -4188,7 +4188,7 @@
       </p:pic>
       <p:sp>
         <p:nvSpPr>
-          <p:cNvPr id="11" name="Text 6"/>
+          <p:cNvPr id="11" name="texto-34"/>
           <p:cNvSpPr txBox="1"/>
           <p:nvPr/>
         </p:nvSpPr>
@@ -4227,7 +4227,7 @@
       </p:sp>
       <p:sp>
         <p:nvSpPr>
-          <p:cNvPr id="12" name="Text 7"/>
+          <p:cNvPr id="12" name="texto-35"/>
           <p:cNvSpPr txBox="1"/>
           <p:nvPr/>
         </p:nvSpPr>
@@ -4266,7 +4266,7 @@
       </p:sp>
       <p:sp>
         <p:nvSpPr>
-          <p:cNvPr id="13" name="Text 8"/>
+          <p:cNvPr id="13" name="texto-36"/>
           <p:cNvSpPr txBox="1"/>
           <p:nvPr/>
         </p:nvSpPr>
@@ -4305,7 +4305,7 @@
       </p:sp>
       <p:pic>
         <p:nvPicPr>
-          <p:cNvPr id="14" name="seta" descr="preencoded.png">    </p:cNvPr>
+          <p:cNvPr id="14" name="seta-37" descr="preencoded.png">    </p:cNvPr>
           <p:cNvPicPr>
             <a:picLocks noChangeAspect="1"/>
           </p:cNvPicPr>
@@ -4329,7 +4329,7 @@
       </p:pic>
       <p:sp>
         <p:nvSpPr>
-          <p:cNvPr id="15" name="icone-fundo"/>
+          <p:cNvPr id="15" name="icone-fundo-38"/>
           <p:cNvSpPr/>
           <p:nvPr/>
         </p:nvSpPr>
@@ -4349,7 +4349,7 @@
       </p:sp>
       <p:pic>
         <p:nvPicPr>
-          <p:cNvPr id="16" name="icone" descr="preencoded.png">    </p:cNvPr>
+          <p:cNvPr id="16" name="icone-39" descr="preencoded.png">    </p:cNvPr>
           <p:cNvPicPr>
             <a:picLocks noChangeAspect="1"/>
           </p:cNvPicPr>
@@ -4373,7 +4373,7 @@
       </p:pic>
       <p:sp>
         <p:nvSpPr>
-          <p:cNvPr id="17" name="Text 10"/>
+          <p:cNvPr id="17" name="texto-40"/>
           <p:cNvSpPr txBox="1"/>
           <p:nvPr/>
         </p:nvSpPr>
@@ -4412,7 +4412,7 @@
       </p:sp>
       <p:sp>
         <p:nvSpPr>
-          <p:cNvPr id="18" name="Text 11"/>
+          <p:cNvPr id="18" name="texto-41"/>
           <p:cNvSpPr txBox="1"/>
           <p:nvPr/>
         </p:nvSpPr>
@@ -4451,7 +4451,7 @@
       </p:sp>
       <p:sp>
         <p:nvSpPr>
-          <p:cNvPr id="19" name="Text 12"/>
+          <p:cNvPr id="19" name="texto-42"/>
           <p:cNvSpPr txBox="1"/>
           <p:nvPr/>
         </p:nvSpPr>
@@ -4490,7 +4490,7 @@
       </p:sp>
       <p:pic>
         <p:nvPicPr>
-          <p:cNvPr id="20" name="seta" descr="preencoded.png">    </p:cNvPr>
+          <p:cNvPr id="20" name="seta-43" descr="preencoded.png">    </p:cNvPr>
           <p:cNvPicPr>
             <a:picLocks noChangeAspect="1"/>
           </p:cNvPicPr>
@@ -4514,7 +4514,7 @@
       </p:pic>
       <p:sp>
         <p:nvSpPr>
-          <p:cNvPr id="21" name="icone-fundo"/>
+          <p:cNvPr id="21" name="icone-fundo-44"/>
           <p:cNvSpPr/>
           <p:nvPr/>
         </p:nvSpPr>
@@ -4534,7 +4534,7 @@
       </p:sp>
       <p:pic>
         <p:nvPicPr>
-          <p:cNvPr id="22" name="icone" descr="preencoded.png">    </p:cNvPr>
+          <p:cNvPr id="22" name="icone-45" descr="preencoded.png">    </p:cNvPr>
           <p:cNvPicPr>
             <a:picLocks noChangeAspect="1"/>
           </p:cNvPicPr>
@@ -4558,7 +4558,7 @@
       </p:pic>
       <p:sp>
         <p:nvSpPr>
-          <p:cNvPr id="23" name="Text 14"/>
+          <p:cNvPr id="23" name="texto-46"/>
           <p:cNvSpPr txBox="1"/>
           <p:nvPr/>
         </p:nvSpPr>
@@ -4597,7 +4597,7 @@
       </p:sp>
       <p:sp>
         <p:nvSpPr>
-          <p:cNvPr id="24" name="Text 15"/>
+          <p:cNvPr id="24" name="texto-47"/>
           <p:cNvSpPr txBox="1"/>
           <p:nvPr/>
         </p:nvSpPr>
@@ -4636,7 +4636,7 @@
       </p:sp>
       <p:sp>
         <p:nvSpPr>
-          <p:cNvPr id="25" name="Text 16"/>
+          <p:cNvPr id="25" name="texto-48"/>
           <p:cNvSpPr txBox="1"/>
           <p:nvPr/>
         </p:nvSpPr>
@@ -4675,7 +4675,7 @@
       </p:sp>
       <p:sp>
         <p:nvSpPr>
-          <p:cNvPr id="25" name="Slide Number Placeholder 0"/>
+          <p:cNvPr id="26" name="Slide Number Placeholder 0"/>
           <p:cNvSpPr>
             <a:spLocks noGrp="1"/>
           </p:cNvSpPr>
@@ -4786,7 +4786,7 @@
       </p:sp>
       <p:sp>
         <p:nvSpPr>
-          <p:cNvPr id="3" name="numero"/>
+          <p:cNvPr id="3" name="numero-49"/>
           <p:cNvSpPr/>
           <p:nvPr/>
         </p:nvSpPr>
@@ -4806,7 +4806,7 @@
       </p:sp>
       <p:sp>
         <p:nvSpPr>
-          <p:cNvPr id="4" name="Text 2"/>
+          <p:cNvPr id="4" name="texto-50"/>
           <p:cNvSpPr txBox="1"/>
           <p:nvPr/>
         </p:nvSpPr>
@@ -4845,7 +4845,7 @@
       </p:sp>
       <p:sp>
         <p:nvSpPr>
-          <p:cNvPr id="5" name="Text 3"/>
+          <p:cNvPr id="5" name="texto-51"/>
           <p:cNvSpPr txBox="1"/>
           <p:nvPr/>
         </p:nvSpPr>
@@ -4884,7 +4884,7 @@
       </p:sp>
       <p:sp>
         <p:nvSpPr>
-          <p:cNvPr id="6" name="Text 4"/>
+          <p:cNvPr id="6" name="texto-52"/>
           <p:cNvSpPr txBox="1"/>
           <p:nvPr/>
         </p:nvSpPr>
@@ -4923,7 +4923,7 @@
       </p:sp>
       <p:sp>
         <p:nvSpPr>
-          <p:cNvPr id="7" name="numero"/>
+          <p:cNvPr id="7" name="numero-53"/>
           <p:cNvSpPr/>
           <p:nvPr/>
         </p:nvSpPr>
@@ -4943,7 +4943,7 @@
       </p:sp>
       <p:sp>
         <p:nvSpPr>
-          <p:cNvPr id="8" name="Text 6"/>
+          <p:cNvPr id="8" name="texto-54"/>
           <p:cNvSpPr txBox="1"/>
           <p:nvPr/>
         </p:nvSpPr>
@@ -4982,7 +4982,7 @@
       </p:sp>
       <p:sp>
         <p:nvSpPr>
-          <p:cNvPr id="9" name="Text 7"/>
+          <p:cNvPr id="9" name="texto-55"/>
           <p:cNvSpPr txBox="1"/>
           <p:nvPr/>
         </p:nvSpPr>
@@ -5021,7 +5021,7 @@
       </p:sp>
       <p:sp>
         <p:nvSpPr>
-          <p:cNvPr id="10" name="Text 8"/>
+          <p:cNvPr id="10" name="texto-56"/>
           <p:cNvSpPr txBox="1"/>
           <p:nvPr/>
         </p:nvSpPr>
@@ -5060,7 +5060,7 @@
       </p:sp>
       <p:sp>
         <p:nvSpPr>
-          <p:cNvPr id="11" name="numero"/>
+          <p:cNvPr id="11" name="numero-57"/>
           <p:cNvSpPr/>
           <p:nvPr/>
         </p:nvSpPr>
@@ -5080,7 +5080,7 @@
       </p:sp>
       <p:sp>
         <p:nvSpPr>
-          <p:cNvPr id="12" name="Text 10"/>
+          <p:cNvPr id="12" name="texto-58"/>
           <p:cNvSpPr txBox="1"/>
           <p:nvPr/>
         </p:nvSpPr>
@@ -5119,7 +5119,7 @@
       </p:sp>
       <p:sp>
         <p:nvSpPr>
-          <p:cNvPr id="13" name="Text 11"/>
+          <p:cNvPr id="13" name="texto-59"/>
           <p:cNvSpPr txBox="1"/>
           <p:nvPr/>
         </p:nvSpPr>
@@ -5158,7 +5158,7 @@
       </p:sp>
       <p:sp>
         <p:nvSpPr>
-          <p:cNvPr id="14" name="Text 12"/>
+          <p:cNvPr id="14" name="texto-60"/>
           <p:cNvSpPr txBox="1"/>
           <p:nvPr/>
         </p:nvSpPr>
@@ -5197,7 +5197,7 @@
       </p:sp>
       <p:sp>
         <p:nvSpPr>
-          <p:cNvPr id="15" name="numero"/>
+          <p:cNvPr id="15" name="numero-61"/>
           <p:cNvSpPr/>
           <p:nvPr/>
         </p:nvSpPr>
@@ -5217,7 +5217,7 @@
       </p:sp>
       <p:sp>
         <p:nvSpPr>
-          <p:cNvPr id="16" name="Text 14"/>
+          <p:cNvPr id="16" name="texto-62"/>
           <p:cNvSpPr txBox="1"/>
           <p:nvPr/>
         </p:nvSpPr>
@@ -5256,7 +5256,7 @@
       </p:sp>
       <p:sp>
         <p:nvSpPr>
-          <p:cNvPr id="17" name="Text 15"/>
+          <p:cNvPr id="17" name="texto-63"/>
           <p:cNvSpPr txBox="1"/>
           <p:nvPr/>
         </p:nvSpPr>
@@ -5295,7 +5295,7 @@
       </p:sp>
       <p:sp>
         <p:nvSpPr>
-          <p:cNvPr id="18" name="Text 16"/>
+          <p:cNvPr id="18" name="texto-64"/>
           <p:cNvSpPr txBox="1"/>
           <p:nvPr/>
         </p:nvSpPr>
@@ -5334,7 +5334,7 @@
       </p:sp>
       <p:sp>
         <p:nvSpPr>
-          <p:cNvPr id="19" name="celular"/>
+          <p:cNvPr id="19" name="celular-65"/>
           <p:cNvSpPr/>
           <p:nvPr/>
         </p:nvSpPr>
@@ -5363,7 +5363,7 @@
       </p:sp>
       <p:sp>
         <p:nvSpPr>
-          <p:cNvPr id="20" name="tela"/>
+          <p:cNvPr id="20" name="tela-66"/>
           <p:cNvSpPr/>
           <p:nvPr/>
         </p:nvSpPr>
@@ -5385,7 +5385,7 @@
       </p:sp>
       <p:sp>
         <p:nvSpPr>
-          <p:cNvPr id="21" name="Text 19"/>
+          <p:cNvPr id="21" name="texto-67"/>
           <p:cNvSpPr txBox="1"/>
           <p:nvPr/>
         </p:nvSpPr>
@@ -5424,7 +5424,7 @@
       </p:sp>
       <p:sp>
         <p:nvSpPr>
-          <p:cNvPr id="22" name="Text 20"/>
+          <p:cNvPr id="22" name="texto-68"/>
           <p:cNvSpPr txBox="1"/>
           <p:nvPr/>
         </p:nvSpPr>
@@ -5463,7 +5463,7 @@
       </p:sp>
       <p:sp>
         <p:nvSpPr>
-          <p:cNvPr id="23" name="Text 21"/>
+          <p:cNvPr id="23" name="texto-69"/>
           <p:cNvSpPr txBox="1"/>
           <p:nvPr/>
         </p:nvSpPr>
@@ -5502,7 +5502,7 @@
       </p:sp>
       <p:sp>
         <p:nvSpPr>
-          <p:cNvPr id="24" name="opcao"/>
+          <p:cNvPr id="24" name="opcao-70"/>
           <p:cNvSpPr/>
           <p:nvPr/>
         </p:nvSpPr>
@@ -5529,7 +5529,7 @@
       </p:sp>
       <p:sp>
         <p:nvSpPr>
-          <p:cNvPr id="25" name="Text 23"/>
+          <p:cNvPr id="25" name="texto-71"/>
           <p:cNvSpPr txBox="1"/>
           <p:nvPr/>
         </p:nvSpPr>
@@ -5568,7 +5568,7 @@
       </p:sp>
       <p:sp>
         <p:nvSpPr>
-          <p:cNvPr id="26" name="opcao"/>
+          <p:cNvPr id="26" name="opcao-72"/>
           <p:cNvSpPr/>
           <p:nvPr/>
         </p:nvSpPr>
@@ -5590,7 +5590,7 @@
       </p:sp>
       <p:sp>
         <p:nvSpPr>
-          <p:cNvPr id="27" name="Text 25"/>
+          <p:cNvPr id="27" name="texto-73"/>
           <p:cNvSpPr txBox="1"/>
           <p:nvPr/>
         </p:nvSpPr>
@@ -5629,7 +5629,7 @@
       </p:sp>
       <p:sp>
         <p:nvSpPr>
-          <p:cNvPr id="28" name="Text 26"/>
+          <p:cNvPr id="28" name="texto-74"/>
           <p:cNvSpPr txBox="1"/>
           <p:nvPr/>
         </p:nvSpPr>
@@ -5668,7 +5668,7 @@
       </p:sp>
       <p:sp>
         <p:nvSpPr>
-          <p:cNvPr id="29" name="opcao"/>
+          <p:cNvPr id="29" name="opcao-75"/>
           <p:cNvSpPr/>
           <p:nvPr/>
         </p:nvSpPr>
@@ -5695,7 +5695,7 @@
       </p:sp>
       <p:sp>
         <p:nvSpPr>
-          <p:cNvPr id="30" name="Text 28"/>
+          <p:cNvPr id="30" name="texto-76"/>
           <p:cNvSpPr txBox="1"/>
           <p:nvPr/>
         </p:nvSpPr>
@@ -5734,7 +5734,7 @@
       </p:sp>
       <p:sp>
         <p:nvSpPr>
-          <p:cNvPr id="31" name="opcao"/>
+          <p:cNvPr id="31" name="opcao-77"/>
           <p:cNvSpPr/>
           <p:nvPr/>
         </p:nvSpPr>
@@ -5756,7 +5756,7 @@
       </p:sp>
       <p:sp>
         <p:nvSpPr>
-          <p:cNvPr id="32" name="Text 30"/>
+          <p:cNvPr id="32" name="texto-78"/>
           <p:cNvSpPr txBox="1"/>
           <p:nvPr/>
         </p:nvSpPr>
@@ -5795,7 +5795,7 @@
       </p:sp>
       <p:sp>
         <p:nvSpPr>
-          <p:cNvPr id="33" name="botao"/>
+          <p:cNvPr id="33" name="botao-79"/>
           <p:cNvSpPr/>
           <p:nvPr/>
         </p:nvSpPr>
@@ -5817,7 +5817,7 @@
       </p:sp>
       <p:sp>
         <p:nvSpPr>
-          <p:cNvPr id="34" name="Text 32"/>
+          <p:cNvPr id="34" name="texto-80"/>
           <p:cNvSpPr txBox="1"/>
           <p:nvPr/>
         </p:nvSpPr>
@@ -5856,7 +5856,7 @@
       </p:sp>
       <p:sp>
         <p:nvSpPr>
-          <p:cNvPr id="25" name="Slide Number Placeholder 0"/>
+          <p:cNvPr id="35" name="Slide Number Placeholder 0"/>
           <p:cNvSpPr>
             <a:spLocks noGrp="1"/>
           </p:cNvSpPr>
@@ -5967,7 +5967,7 @@
       </p:sp>
       <p:sp>
         <p:nvSpPr>
-          <p:cNvPr id="3" name="Text 1"/>
+          <p:cNvPr id="3" name="texto-81"/>
           <p:cNvSpPr txBox="1"/>
           <p:nvPr/>
         </p:nvSpPr>
@@ -6006,7 +6006,7 @@
       </p:sp>
       <p:sp>
         <p:nvSpPr>
-          <p:cNvPr id="4" name="Text 2"/>
+          <p:cNvPr id="4" name="texto-82"/>
           <p:cNvSpPr txBox="1"/>
           <p:nvPr/>
         </p:nvSpPr>
@@ -6045,7 +6045,7 @@
       </p:sp>
       <p:sp>
         <p:nvSpPr>
-          <p:cNvPr id="5" name="cartao-visita"/>
+          <p:cNvPr id="5" name="cartao-visita-83"/>
           <p:cNvSpPr/>
           <p:nvPr/>
         </p:nvSpPr>
@@ -6079,7 +6079,7 @@
       </p:sp>
       <p:sp>
         <p:nvSpPr>
-          <p:cNvPr id="6" name="Text 4"/>
+          <p:cNvPr id="6" name="texto-84"/>
           <p:cNvSpPr txBox="1"/>
           <p:nvPr/>
         </p:nvSpPr>
@@ -6118,7 +6118,7 @@
       </p:sp>
       <p:sp>
         <p:nvSpPr>
-          <p:cNvPr id="7" name="Text 5"/>
+          <p:cNvPr id="7" name="texto-85"/>
           <p:cNvSpPr txBox="1"/>
           <p:nvPr/>
         </p:nvSpPr>
@@ -6157,7 +6157,7 @@
       </p:sp>
       <p:sp>
         <p:nvSpPr>
-          <p:cNvPr id="8" name="Text 6"/>
+          <p:cNvPr id="8" name="texto-86"/>
           <p:cNvSpPr txBox="1"/>
           <p:nvPr/>
         </p:nvSpPr>
@@ -6196,7 +6196,7 @@
       </p:sp>
       <p:sp>
         <p:nvSpPr>
-          <p:cNvPr id="9" name="selo"/>
+          <p:cNvPr id="9" name="selo-87"/>
           <p:cNvSpPr/>
           <p:nvPr/>
         </p:nvSpPr>
@@ -6218,7 +6218,7 @@
       </p:sp>
       <p:sp>
         <p:nvSpPr>
-          <p:cNvPr id="10" name="Text 8"/>
+          <p:cNvPr id="10" name="texto-88"/>
           <p:cNvSpPr txBox="1"/>
           <p:nvPr/>
         </p:nvSpPr>
@@ -6257,7 +6257,7 @@
       </p:sp>
       <p:sp>
         <p:nvSpPr>
-          <p:cNvPr id="11" name="selo"/>
+          <p:cNvPr id="11" name="selo-89"/>
           <p:cNvSpPr/>
           <p:nvPr/>
         </p:nvSpPr>
@@ -6279,7 +6279,7 @@
       </p:sp>
       <p:sp>
         <p:nvSpPr>
-          <p:cNvPr id="12" name="Text 10"/>
+          <p:cNvPr id="12" name="texto-90"/>
           <p:cNvSpPr txBox="1"/>
           <p:nvPr/>
         </p:nvSpPr>
@@ -6318,7 +6318,7 @@
       </p:sp>
       <p:sp>
         <p:nvSpPr>
-          <p:cNvPr id="25" name="Slide Number Placeholder 0"/>
+          <p:cNvPr id="13" name="Slide Number Placeholder 0"/>
           <p:cNvSpPr>
             <a:spLocks noGrp="1"/>
           </p:cNvSpPr>
@@ -6429,7 +6429,7 @@
       </p:sp>
       <p:sp>
         <p:nvSpPr>
-          <p:cNvPr id="3" name="cartao"/>
+          <p:cNvPr id="3" name="cartao-91"/>
           <p:cNvSpPr/>
           <p:nvPr/>
         </p:nvSpPr>
@@ -6451,7 +6451,7 @@
       </p:sp>
       <p:sp>
         <p:nvSpPr>
-          <p:cNvPr id="4" name="icone-fundo"/>
+          <p:cNvPr id="4" name="icone-fundo-92"/>
           <p:cNvSpPr/>
           <p:nvPr/>
         </p:nvSpPr>
@@ -6471,7 +6471,7 @@
       </p:sp>
       <p:pic>
         <p:nvPicPr>
-          <p:cNvPr id="5" name="icone" descr="preencoded.png">    </p:cNvPr>
+          <p:cNvPr id="5" name="icone-93" descr="preencoded.png">    </p:cNvPr>
           <p:cNvPicPr>
             <a:picLocks noChangeAspect="1"/>
           </p:cNvPicPr>
@@ -6495,7 +6495,7 @@
       </p:pic>
       <p:sp>
         <p:nvSpPr>
-          <p:cNvPr id="6" name="Text 3"/>
+          <p:cNvPr id="6" name="texto-94"/>
           <p:cNvSpPr txBox="1"/>
           <p:nvPr/>
         </p:nvSpPr>
@@ -6534,7 +6534,7 @@
       </p:sp>
       <p:sp>
         <p:nvSpPr>
-          <p:cNvPr id="7" name="Text 4"/>
+          <p:cNvPr id="7" name="texto-95"/>
           <p:cNvSpPr txBox="1"/>
           <p:nvPr/>
         </p:nvSpPr>
@@ -6573,7 +6573,7 @@
       </p:sp>
       <p:sp>
         <p:nvSpPr>
-          <p:cNvPr id="8" name="cartao"/>
+          <p:cNvPr id="8" name="cartao-96"/>
           <p:cNvSpPr/>
           <p:nvPr/>
         </p:nvSpPr>
@@ -6595,7 +6595,7 @@
       </p:sp>
       <p:sp>
         <p:nvSpPr>
-          <p:cNvPr id="9" name="icone-fundo"/>
+          <p:cNvPr id="9" name="icone-fundo-97"/>
           <p:cNvSpPr/>
           <p:nvPr/>
         </p:nvSpPr>
@@ -6615,7 +6615,7 @@
       </p:sp>
       <p:pic>
         <p:nvPicPr>
-          <p:cNvPr id="10" name="icone" descr="preencoded.png">    </p:cNvPr>
+          <p:cNvPr id="10" name="icone-98" descr="preencoded.png">    </p:cNvPr>
           <p:cNvPicPr>
             <a:picLocks noChangeAspect="1"/>
           </p:cNvPicPr>
@@ -6639,7 +6639,7 @@
       </p:pic>
       <p:sp>
         <p:nvSpPr>
-          <p:cNvPr id="11" name="Text 7"/>
+          <p:cNvPr id="11" name="texto-99"/>
           <p:cNvSpPr txBox="1"/>
           <p:nvPr/>
         </p:nvSpPr>
@@ -6678,7 +6678,7 @@
       </p:sp>
       <p:sp>
         <p:nvSpPr>
-          <p:cNvPr id="12" name="Text 8"/>
+          <p:cNvPr id="12" name="texto-100"/>
           <p:cNvSpPr txBox="1"/>
           <p:nvPr/>
         </p:nvSpPr>
@@ -6717,7 +6717,7 @@
       </p:sp>
       <p:sp>
         <p:nvSpPr>
-          <p:cNvPr id="13" name="cartao"/>
+          <p:cNvPr id="13" name="cartao-101"/>
           <p:cNvSpPr/>
           <p:nvPr/>
         </p:nvSpPr>
@@ -6739,7 +6739,7 @@
       </p:sp>
       <p:sp>
         <p:nvSpPr>
-          <p:cNvPr id="14" name="icone-fundo"/>
+          <p:cNvPr id="14" name="icone-fundo-102"/>
           <p:cNvSpPr/>
           <p:nvPr/>
         </p:nvSpPr>
@@ -6759,7 +6759,7 @@
       </p:sp>
       <p:pic>
         <p:nvPicPr>
-          <p:cNvPr id="15" name="icone" descr="preencoded.png">    </p:cNvPr>
+          <p:cNvPr id="15" name="icone-103" descr="preencoded.png">    </p:cNvPr>
           <p:cNvPicPr>
             <a:picLocks noChangeAspect="1"/>
           </p:cNvPicPr>
@@ -6783,7 +6783,7 @@
       </p:pic>
       <p:sp>
         <p:nvSpPr>
-          <p:cNvPr id="16" name="Text 11"/>
+          <p:cNvPr id="16" name="texto-104"/>
           <p:cNvSpPr txBox="1"/>
           <p:nvPr/>
         </p:nvSpPr>
@@ -6822,7 +6822,7 @@
       </p:sp>
       <p:sp>
         <p:nvSpPr>
-          <p:cNvPr id="17" name="Text 12"/>
+          <p:cNvPr id="17" name="texto-105"/>
           <p:cNvSpPr txBox="1"/>
           <p:nvPr/>
         </p:nvSpPr>
@@ -6861,7 +6861,7 @@
       </p:sp>
       <p:sp>
         <p:nvSpPr>
-          <p:cNvPr id="18" name="cartao"/>
+          <p:cNvPr id="18" name="cartao-106"/>
           <p:cNvSpPr/>
           <p:nvPr/>
         </p:nvSpPr>
@@ -6883,7 +6883,7 @@
       </p:sp>
       <p:sp>
         <p:nvSpPr>
-          <p:cNvPr id="19" name="icone-fundo"/>
+          <p:cNvPr id="19" name="icone-fundo-107"/>
           <p:cNvSpPr/>
           <p:nvPr/>
         </p:nvSpPr>
@@ -6903,7 +6903,7 @@
       </p:sp>
       <p:pic>
         <p:nvPicPr>
-          <p:cNvPr id="20" name="icone" descr="preencoded.png">    </p:cNvPr>
+          <p:cNvPr id="20" name="icone-108" descr="preencoded.png">    </p:cNvPr>
           <p:cNvPicPr>
             <a:picLocks noChangeAspect="1"/>
           </p:cNvPicPr>
@@ -6927,7 +6927,7 @@
       </p:pic>
       <p:sp>
         <p:nvSpPr>
-          <p:cNvPr id="21" name="Text 15"/>
+          <p:cNvPr id="21" name="texto-109"/>
           <p:cNvSpPr txBox="1"/>
           <p:nvPr/>
         </p:nvSpPr>
@@ -6966,7 +6966,7 @@
       </p:sp>
       <p:sp>
         <p:nvSpPr>
-          <p:cNvPr id="22" name="Text 16"/>
+          <p:cNvPr id="22" name="texto-110"/>
           <p:cNvSpPr txBox="1"/>
           <p:nvPr/>
         </p:nvSpPr>
@@ -7005,7 +7005,7 @@
       </p:sp>
       <p:sp>
         <p:nvSpPr>
-          <p:cNvPr id="25" name="Slide Number Placeholder 0"/>
+          <p:cNvPr id="23" name="Slide Number Placeholder 0"/>
           <p:cNvSpPr>
             <a:spLocks noGrp="1"/>
           </p:cNvSpPr>
@@ -7217,7 +7217,7 @@
       </p:sp>
       <p:sp>
         <p:nvSpPr>
-          <p:cNvPr id="3" name="icone-fundo"/>
+          <p:cNvPr id="3" name="icone-fundo-111"/>
           <p:cNvSpPr/>
           <p:nvPr/>
         </p:nvSpPr>
@@ -7237,7 +7237,7 @@
       </p:sp>
       <p:pic>
         <p:nvPicPr>
-          <p:cNvPr id="4" name="icone" descr="preencoded.png">    </p:cNvPr>
+          <p:cNvPr id="4" name="icone-112" descr="preencoded.png">    </p:cNvPr>
           <p:cNvPicPr>
             <a:picLocks noChangeAspect="1"/>
           </p:cNvPicPr>
@@ -7261,7 +7261,7 @@
       </p:pic>
       <p:sp>
         <p:nvSpPr>
-          <p:cNvPr id="5" name="Text 2"/>
+          <p:cNvPr id="5" name="texto-113"/>
           <p:cNvSpPr txBox="1"/>
           <p:nvPr/>
         </p:nvSpPr>
@@ -7300,7 +7300,7 @@
       </p:sp>
       <p:sp>
         <p:nvSpPr>
-          <p:cNvPr id="6" name="Text 3"/>
+          <p:cNvPr id="6" name="texto-114"/>
           <p:cNvSpPr txBox="1"/>
           <p:nvPr/>
         </p:nvSpPr>
@@ -7339,7 +7339,7 @@
       </p:sp>
       <p:sp>
         <p:nvSpPr>
-          <p:cNvPr id="7" name="icone-fundo"/>
+          <p:cNvPr id="7" name="icone-fundo-115"/>
           <p:cNvSpPr/>
           <p:nvPr/>
         </p:nvSpPr>
@@ -7359,7 +7359,7 @@
       </p:sp>
       <p:pic>
         <p:nvPicPr>
-          <p:cNvPr id="8" name="icone" descr="preencoded.png">    </p:cNvPr>
+          <p:cNvPr id="8" name="icone-116" descr="preencoded.png">    </p:cNvPr>
           <p:cNvPicPr>
             <a:picLocks noChangeAspect="1"/>
           </p:cNvPicPr>
@@ -7383,7 +7383,7 @@
       </p:pic>
       <p:sp>
         <p:nvSpPr>
-          <p:cNvPr id="9" name="Text 5"/>
+          <p:cNvPr id="9" name="texto-117"/>
           <p:cNvSpPr txBox="1"/>
           <p:nvPr/>
         </p:nvSpPr>
@@ -7422,7 +7422,7 @@
       </p:sp>
       <p:sp>
         <p:nvSpPr>
-          <p:cNvPr id="10" name="Text 6"/>
+          <p:cNvPr id="10" name="texto-118"/>
           <p:cNvSpPr txBox="1"/>
           <p:nvPr/>
         </p:nvSpPr>
@@ -7461,7 +7461,7 @@
       </p:sp>
       <p:sp>
         <p:nvSpPr>
-          <p:cNvPr id="11" name="icone-fundo"/>
+          <p:cNvPr id="11" name="icone-fundo-119"/>
           <p:cNvSpPr/>
           <p:nvPr/>
         </p:nvSpPr>
@@ -7481,7 +7481,7 @@
       </p:sp>
       <p:pic>
         <p:nvPicPr>
-          <p:cNvPr id="12" name="icone" descr="preencoded.png">    </p:cNvPr>
+          <p:cNvPr id="12" name="icone-120" descr="preencoded.png">    </p:cNvPr>
           <p:cNvPicPr>
             <a:picLocks noChangeAspect="1"/>
           </p:cNvPicPr>
@@ -7505,7 +7505,7 @@
       </p:pic>
       <p:sp>
         <p:nvSpPr>
-          <p:cNvPr id="13" name="Text 8"/>
+          <p:cNvPr id="13" name="texto-121"/>
           <p:cNvSpPr txBox="1"/>
           <p:nvPr/>
         </p:nvSpPr>
@@ -7544,7 +7544,7 @@
       </p:sp>
       <p:sp>
         <p:nvSpPr>
-          <p:cNvPr id="14" name="Text 9"/>
+          <p:cNvPr id="14" name="texto-122"/>
           <p:cNvSpPr txBox="1"/>
           <p:nvPr/>
         </p:nvSpPr>
@@ -7583,7 +7583,7 @@
       </p:sp>
       <p:sp>
         <p:nvSpPr>
-          <p:cNvPr id="25" name="Slide Number Placeholder 0"/>
+          <p:cNvPr id="15" name="Slide Number Placeholder 0"/>
           <p:cNvSpPr>
             <a:spLocks noGrp="1"/>
           </p:cNvSpPr>

</xml_diff>